<commit_message>
Otus changes on 2025-07-16
</commit_message>
<xml_diff>
--- a/ML Adv/31 - Docker nets & compose/Presentation/31 - Docker nets & compose.pptx
+++ b/ML Adv/31 - Docker nets & compose/Presentation/31 - Docker nets & compose.pptx
@@ -5793,7 +5793,7 @@
           <a:p>
             <a:fld id="{1D8BD707-D9CF-40AE-B4C6-C98DA3205C09}" type="datetimeFigureOut">
               <a:rPr lang="en-US"/>
-              <a:t>5/15/25</a:t>
+              <a:t>7/8/25</a:t>
             </a:fld>
             <a:endParaRPr lang="en-US"/>
           </a:p>
@@ -20526,12 +20526,8 @@
           <a:p>
             <a:pPr marL="0" indent="0"/>
             <a:r>
-              <a:rPr lang="en-US" dirty="0"/>
-              <a:t>03.09 - </a:t>
-            </a:r>
-            <a:r>
               <a:rPr lang="ru-RU" dirty="0" err="1"/>
-              <a:t>деплой</a:t>
+              <a:t>Деплой</a:t>
             </a:r>
             <a:r>
               <a:rPr lang="ru-RU" dirty="0"/>

</xml_diff>